<commit_message>
Add search command to cover slide
Co-Authored-By: Claude Opus 5.5 <noreply@anthropic.com>
Claude-Session: https://claude.ai/code/session_015yu1chgjRjg41XkdwnnPd4
</commit_message>
<xml_diff>
--- a/presentation/Meniscus_Exercise_vs_Surgery.pptx
+++ b/presentation/Meniscus_Exercise_vs_Surgery.pptx
@@ -3288,8 +3288,8 @@
         </p:nvSpPr>
         <p:spPr>
           <a:xfrm>
-            <a:off x="731520" y="3429000"/>
-            <a:ext cx="8412480" cy="1097280"/>
+            <a:off x="731520" y="3200400"/>
+            <a:ext cx="8412480" cy="914400"/>
           </a:xfrm>
           <a:prstGeom prst="rect">
             <a:avLst/>
@@ -3327,8 +3327,8 @@
         </p:nvSpPr>
         <p:spPr>
           <a:xfrm>
-            <a:off x="731520" y="4526280"/>
-            <a:ext cx="8412480" cy="822960"/>
+            <a:off x="731520" y="4023360"/>
+            <a:ext cx="8412480" cy="731520"/>
           </a:xfrm>
           <a:prstGeom prst="rect">
             <a:avLst/>
@@ -3376,7 +3376,91 @@
       </p:sp>
       <p:sp>
         <p:nvSpPr>
-          <p:cNvPr id="9" name="TextBox 8"/>
+          <p:cNvPr id="9" name="Rounded Rectangle 8"/>
+          <p:cNvSpPr/>
+          <p:nvPr/>
+        </p:nvSpPr>
+        <p:spPr>
+          <a:xfrm>
+            <a:off x="731520" y="4846320"/>
+            <a:ext cx="10698480" cy="548640"/>
+          </a:xfrm>
+          <a:prstGeom prst="roundRect">
+            <a:avLst>
+              <a:gd name="adj" fmla="val 8000"/>
+            </a:avLst>
+          </a:prstGeom>
+          <a:solidFill>
+            <a:srgbClr val="2B4D6E"/>
+          </a:solidFill>
+          <a:ln>
+            <a:noFill/>
+          </a:ln>
+        </p:spPr>
+        <p:style>
+          <a:lnRef idx="1">
+            <a:schemeClr val="accent1"/>
+          </a:lnRef>
+          <a:fillRef idx="3">
+            <a:schemeClr val="accent1"/>
+          </a:fillRef>
+          <a:effectRef idx="2">
+            <a:schemeClr val="accent1"/>
+          </a:effectRef>
+          <a:fontRef idx="minor">
+            <a:schemeClr val="lt1"/>
+          </a:fontRef>
+        </p:style>
+        <p:txBody>
+          <a:bodyPr rtlCol="0" anchor="ctr"/>
+          <a:lstStyle/>
+          <a:p>
+            <a:pPr algn="ctr"/>
+          </a:p>
+        </p:txBody>
+      </p:sp>
+      <p:sp>
+        <p:nvSpPr>
+          <p:cNvPr id="10" name="TextBox 9"/>
+          <p:cNvSpPr txBox="1"/>
+          <p:nvPr/>
+        </p:nvSpPr>
+        <p:spPr>
+          <a:xfrm>
+            <a:off x="868680" y="4846320"/>
+            <a:ext cx="10515600" cy="548640"/>
+          </a:xfrm>
+          <a:prstGeom prst="rect">
+            <a:avLst/>
+          </a:prstGeom>
+          <a:noFill/>
+        </p:spPr>
+        <p:txBody>
+          <a:bodyPr wrap="square" anchor="ctr" lIns="73152" rIns="73152">
+            <a:spAutoFit/>
+          </a:bodyPr>
+          <a:lstStyle/>
+          <a:p>
+            <a:pPr algn="l">
+              <a:spcAft>
+                <a:spcPts val="400"/>
+              </a:spcAft>
+            </a:pPr>
+            <a:r>
+              <a:rPr sz="1700" b="1">
+                <a:solidFill>
+                  <a:srgbClr val="FFFFFF"/>
+                </a:solidFill>
+                <a:latin typeface="Sarabun"/>
+              </a:rPr>
+              <a:t>คำสั่งค้นหา:  Meniscus injury and Bursitis  →  การออกกำลังกาย (Exercise)</a:t>
+            </a:r>
+          </a:p>
+        </p:txBody>
+      </p:sp>
+      <p:sp>
+        <p:nvSpPr>
+          <p:cNvPr id="11" name="TextBox 10"/>
           <p:cNvSpPr txBox="1"/>
           <p:nvPr/>
         </p:nvSpPr>

</xml_diff>

<commit_message>
Remove search command from cover slide
Co-Authored-By: Claude Opus 5.5 <noreply@anthropic.com>
Claude-Session: https://claude.ai/code/session_015yu1chgjRjg41XkdwnnPd4
</commit_message>
<xml_diff>
--- a/presentation/Meniscus_Exercise_vs_Surgery.pptx
+++ b/presentation/Meniscus_Exercise_vs_Surgery.pptx
@@ -3288,8 +3288,8 @@
         </p:nvSpPr>
         <p:spPr>
           <a:xfrm>
-            <a:off x="731520" y="3200400"/>
-            <a:ext cx="8412480" cy="914400"/>
+            <a:off x="731520" y="3429000"/>
+            <a:ext cx="8412480" cy="1097280"/>
           </a:xfrm>
           <a:prstGeom prst="rect">
             <a:avLst/>
@@ -3327,8 +3327,8 @@
         </p:nvSpPr>
         <p:spPr>
           <a:xfrm>
-            <a:off x="731520" y="4023360"/>
-            <a:ext cx="8412480" cy="731520"/>
+            <a:off x="731520" y="4526280"/>
+            <a:ext cx="8412480" cy="822960"/>
           </a:xfrm>
           <a:prstGeom prst="rect">
             <a:avLst/>
@@ -3376,91 +3376,7 @@
       </p:sp>
       <p:sp>
         <p:nvSpPr>
-          <p:cNvPr id="9" name="Rounded Rectangle 8"/>
-          <p:cNvSpPr/>
-          <p:nvPr/>
-        </p:nvSpPr>
-        <p:spPr>
-          <a:xfrm>
-            <a:off x="731520" y="4846320"/>
-            <a:ext cx="10698480" cy="548640"/>
-          </a:xfrm>
-          <a:prstGeom prst="roundRect">
-            <a:avLst>
-              <a:gd name="adj" fmla="val 8000"/>
-            </a:avLst>
-          </a:prstGeom>
-          <a:solidFill>
-            <a:srgbClr val="2B4D6E"/>
-          </a:solidFill>
-          <a:ln>
-            <a:noFill/>
-          </a:ln>
-        </p:spPr>
-        <p:style>
-          <a:lnRef idx="1">
-            <a:schemeClr val="accent1"/>
-          </a:lnRef>
-          <a:fillRef idx="3">
-            <a:schemeClr val="accent1"/>
-          </a:fillRef>
-          <a:effectRef idx="2">
-            <a:schemeClr val="accent1"/>
-          </a:effectRef>
-          <a:fontRef idx="minor">
-            <a:schemeClr val="lt1"/>
-          </a:fontRef>
-        </p:style>
-        <p:txBody>
-          <a:bodyPr rtlCol="0" anchor="ctr"/>
-          <a:lstStyle/>
-          <a:p>
-            <a:pPr algn="ctr"/>
-          </a:p>
-        </p:txBody>
-      </p:sp>
-      <p:sp>
-        <p:nvSpPr>
-          <p:cNvPr id="10" name="TextBox 9"/>
-          <p:cNvSpPr txBox="1"/>
-          <p:nvPr/>
-        </p:nvSpPr>
-        <p:spPr>
-          <a:xfrm>
-            <a:off x="868680" y="4846320"/>
-            <a:ext cx="10515600" cy="548640"/>
-          </a:xfrm>
-          <a:prstGeom prst="rect">
-            <a:avLst/>
-          </a:prstGeom>
-          <a:noFill/>
-        </p:spPr>
-        <p:txBody>
-          <a:bodyPr wrap="square" anchor="ctr" lIns="73152" rIns="73152">
-            <a:spAutoFit/>
-          </a:bodyPr>
-          <a:lstStyle/>
-          <a:p>
-            <a:pPr algn="l">
-              <a:spcAft>
-                <a:spcPts val="400"/>
-              </a:spcAft>
-            </a:pPr>
-            <a:r>
-              <a:rPr sz="1700" b="1">
-                <a:solidFill>
-                  <a:srgbClr val="FFFFFF"/>
-                </a:solidFill>
-                <a:latin typeface="Sarabun"/>
-              </a:rPr>
-              <a:t>คำสั่งค้นหา:  Meniscus injury and Bursitis  →  การออกกำลังกาย (Exercise)</a:t>
-            </a:r>
-          </a:p>
-        </p:txBody>
-      </p:sp>
-      <p:sp>
-        <p:nvSpPr>
-          <p:cNvPr id="11" name="TextBox 10"/>
+          <p:cNvPr id="9" name="TextBox 8"/>
           <p:cNvSpPr txBox="1"/>
           <p:nvPr/>
         </p:nvSpPr>

</xml_diff>